<commit_message>
feat: Update PPt ML Model Slides
</commit_message>
<xml_diff>
--- a/Data_Cleaning/Presenttion PPT.pptx
+++ b/Data_Cleaning/Presenttion PPT.pptx
@@ -793,7 +793,7 @@
           <a:p>
             <a:fld id="{5BCAD085-E8A6-8845-BD4E-CB4CCA059FC4}" type="datetimeFigureOut">
               <a:rPr lang="en-US" smtClean="0"/>
-              <a:t>9/10/2026</a:t>
+              <a:t>9/15/2026</a:t>
             </a:fld>
             <a:endParaRPr lang="en-US"/>
           </a:p>
@@ -20264,9 +20264,9 @@
         <p:grpSpPr>
           <a:xfrm>
             <a:off x="1279728" y="1303622"/>
-            <a:ext cx="3707228" cy="6086052"/>
+            <a:ext cx="3707228" cy="5809053"/>
             <a:chOff x="1279728" y="1303622"/>
-            <a:chExt cx="3707228" cy="6086052"/>
+            <a:chExt cx="3707228" cy="5809053"/>
           </a:xfrm>
         </p:grpSpPr>
         <p:sp>
@@ -20284,7 +20284,7 @@
           <p:spPr>
             <a:xfrm>
               <a:off x="1322168" y="5881569"/>
-              <a:ext cx="3664788" cy="1508105"/>
+              <a:ext cx="3664788" cy="1231106"/>
             </a:xfrm>
             <a:prstGeom prst="rect">
               <a:avLst/>
@@ -20297,15 +20297,17 @@
             </a:bodyPr>
             <a:lstStyle/>
             <a:p>
+              <a:pPr lvl="0"/>
               <a:r>
                 <a:rPr lang="en-IN" sz="2000" b="1" dirty="0"/>
-                <a:t>HR Dataset</a:t>
+                <a:t>Model Development</a:t>
               </a:r>
-            </a:p>
-            <a:p>
+              <a:br>
+                <a:rPr lang="en-IN" sz="2000" b="1" dirty="0"/>
+              </a:br>
               <a:r>
                 <a:rPr lang="en-IN" dirty="0"/>
-                <a:t>Employee workforce data with demographic, job, satisfaction, income and experience features</a:t>
+                <a:t>Build the ML model &amp; train using the prepared workforce data</a:t>
               </a:r>
             </a:p>
             <a:p>
@@ -20330,7 +20332,7 @@
           <p:spPr>
             <a:xfrm>
               <a:off x="1279728" y="3274815"/>
-              <a:ext cx="2696114" cy="1323439"/>
+              <a:ext cx="2696114" cy="1631216"/>
             </a:xfrm>
             <a:prstGeom prst="rect">
               <a:avLst/>
@@ -20343,18 +20345,18 @@
             </a:bodyPr>
             <a:lstStyle/>
             <a:p>
+              <a:pPr lvl="0"/>
               <a:r>
                 <a:rPr lang="en-IN" sz="2000" b="1" dirty="0"/>
-                <a:t>Data Preprocessing</a:t>
+                <a:t>Model Evaluation</a:t>
               </a:r>
-              <a:endParaRPr lang="en-IN" sz="2000" dirty="0"/>
-            </a:p>
-            <a:p>
+              <a:br>
+                <a:rPr lang="en-IN" sz="2000" b="1" dirty="0"/>
+              </a:br>
               <a:r>
                 <a:rPr lang="en-IN" sz="2000" dirty="0"/>
-                <a:t>Clean and prepare the dataset for model training.</a:t>
+                <a:t>Test on unseen records &amp; measure model performance and reliability</a:t>
               </a:r>
-              <a:endParaRPr lang="en-IN" sz="1800" dirty="0"/>
             </a:p>
           </p:txBody>
         </p:sp>
@@ -20373,7 +20375,7 @@
           <p:spPr>
             <a:xfrm>
               <a:off x="1919162" y="1303622"/>
-              <a:ext cx="3012609" cy="1323439"/>
+              <a:ext cx="3012609" cy="1631216"/>
             </a:xfrm>
             <a:prstGeom prst="rect">
               <a:avLst/>
@@ -20386,16 +20388,17 @@
             </a:bodyPr>
             <a:lstStyle/>
             <a:p>
+              <a:pPr lvl="0"/>
               <a:r>
                 <a:rPr lang="en-IN" sz="2000" b="1" dirty="0"/>
-                <a:t>Feature Selection</a:t>
+                <a:t>Prediction &amp; Insights</a:t>
               </a:r>
-              <a:endParaRPr lang="en-IN" sz="2000" dirty="0"/>
-            </a:p>
-            <a:p>
+              <a:br>
+                <a:rPr lang="en-IN" sz="2000" b="1" dirty="0"/>
+              </a:br>
               <a:r>
                 <a:rPr lang="en-IN" sz="2000" dirty="0"/>
-                <a:t>Select relevant employee attributes for predicting attrition.</a:t>
+                <a:t>Generate predictions &amp; use results for workforce/HR analysis and decision-making</a:t>
               </a:r>
             </a:p>
           </p:txBody>
@@ -20653,9 +20656,9 @@
         <p:grpSpPr>
           <a:xfrm>
             <a:off x="9401720" y="1376625"/>
-            <a:ext cx="4111158" cy="5686636"/>
+            <a:ext cx="4111158" cy="5378860"/>
             <a:chOff x="9401720" y="1376625"/>
-            <a:chExt cx="4111158" cy="5686636"/>
+            <a:chExt cx="4111158" cy="5378860"/>
           </a:xfrm>
         </p:grpSpPr>
         <p:sp>
@@ -20688,14 +20691,13 @@
             <a:p>
               <a:r>
                 <a:rPr lang="en-IN" sz="2000" b="1" dirty="0"/>
-                <a:t>Logistic Regression</a:t>
+                <a:t>Data Preparation</a:t>
               </a:r>
-              <a:endParaRPr lang="en-IN" sz="2000" dirty="0"/>
             </a:p>
             <a:p>
               <a:r>
                 <a:rPr lang="en-IN" sz="2000" dirty="0"/>
-                <a:t>Apply Logistic Regression as the classification algorithm.</a:t>
+                <a:t>Collect the cleaned dataset &amp; Check data quality and required fields</a:t>
               </a:r>
             </a:p>
           </p:txBody>
@@ -20730,22 +20732,14 @@
             <a:p>
               <a:r>
                 <a:rPr lang="en-IN" sz="2000" b="1" dirty="0"/>
-                <a:t>Binary Classification</a:t>
+                <a:t>Feature Selection</a:t>
               </a:r>
               <a:br>
                 <a:rPr lang="en-IN" sz="2000" dirty="0"/>
               </a:br>
               <a:r>
                 <a:rPr lang="en-IN" sz="2000" dirty="0"/>
-                <a:t>Predict two outcomes: </a:t>
-              </a:r>
-              <a:r>
-                <a:rPr lang="en-IN" sz="2000" b="1" dirty="0"/>
-                <a:t>Attrition = Yes / No</a:t>
-              </a:r>
-              <a:r>
-                <a:rPr lang="en-IN" sz="2000" dirty="0"/>
-                <a:t>.</a:t>
+                <a:t>Select important employee attributes.</a:t>
               </a:r>
             </a:p>
           </p:txBody>
@@ -20765,7 +20759,7 @@
           <p:spPr>
             <a:xfrm>
               <a:off x="10159284" y="5739822"/>
-              <a:ext cx="3152801" cy="1323439"/>
+              <a:ext cx="3152801" cy="1015663"/>
             </a:xfrm>
             <a:prstGeom prst="rect">
               <a:avLst/>
@@ -20778,16 +20772,17 @@
             </a:bodyPr>
             <a:lstStyle/>
             <a:p>
+              <a:pPr lvl="0"/>
               <a:r>
                 <a:rPr lang="en-IN" sz="2000" b="1" dirty="0"/>
-                <a:t>Attrition Prediction</a:t>
+                <a:t>Data Preprocessing</a:t>
               </a:r>
-              <a:endParaRPr lang="en-IN" sz="2000" dirty="0"/>
-            </a:p>
-            <a:p>
+              <a:br>
+                <a:rPr lang="en-IN" sz="2000" dirty="0"/>
+              </a:br>
               <a:r>
                 <a:rPr lang="en-IN" sz="2000" dirty="0"/>
-                <a:t>Generate the predicted employee attrition probability.</a:t>
+                <a:t>Encode categorical values  &amp; Prepare data for analysis.</a:t>
               </a:r>
             </a:p>
           </p:txBody>

</xml_diff>